<commit_message>
Update README, push changes to final presentation
</commit_message>
<xml_diff>
--- a/Presentation.pptx
+++ b/Presentation.pptx
@@ -12,11 +12,11 @@
     <p:sldId id="261" r:id="rId6"/>
     <p:sldId id="263" r:id="rId7"/>
     <p:sldId id="265" r:id="rId8"/>
-    <p:sldId id="264" r:id="rId9"/>
-    <p:sldId id="267" r:id="rId10"/>
-    <p:sldId id="268" r:id="rId11"/>
-    <p:sldId id="270" r:id="rId12"/>
-    <p:sldId id="262" r:id="rId13"/>
+    <p:sldId id="267" r:id="rId9"/>
+    <p:sldId id="268" r:id="rId10"/>
+    <p:sldId id="270" r:id="rId11"/>
+    <p:sldId id="262" r:id="rId12"/>
+    <p:sldId id="264" r:id="rId13"/>
     <p:sldId id="266" r:id="rId14"/>
     <p:sldId id="269" r:id="rId15"/>
   </p:sldIdLst>
@@ -117,6 +117,11 @@
       </a:defRPr>
     </a:lvl9pPr>
   </p:defaultTextStyle>
+  <p:extLst>
+    <p:ext uri="{EFAFB233-063F-42B5-8137-9DF3F51BA10A}">
+      <p15:sldGuideLst xmlns:p15="http://schemas.microsoft.com/office/powerpoint/2012/main"/>
+    </p:ext>
+  </p:extLst>
 </p:presentation>
 </file>
 
@@ -865,7 +870,7 @@
           <a:p>
             <a:fld id="{6028BAED-B89A-EC45-9ABA-871B3199639E}" type="datetimeFigureOut">
               <a:rPr lang="en-US" smtClean="0"/>
-              <a:t>4/28/26</a:t>
+              <a:t>4/29/26</a:t>
             </a:fld>
             <a:endParaRPr lang="en-US"/>
           </a:p>
@@ -1116,7 +1121,7 @@
           <a:p>
             <a:fld id="{6028BAED-B89A-EC45-9ABA-871B3199639E}" type="datetimeFigureOut">
               <a:rPr lang="en-US" smtClean="0"/>
-              <a:t>4/28/26</a:t>
+              <a:t>4/29/26</a:t>
             </a:fld>
             <a:endParaRPr lang="en-US"/>
           </a:p>
@@ -1430,7 +1435,7 @@
           <a:p>
             <a:fld id="{6028BAED-B89A-EC45-9ABA-871B3199639E}" type="datetimeFigureOut">
               <a:rPr lang="en-US" smtClean="0"/>
-              <a:t>4/28/26</a:t>
+              <a:t>4/29/26</a:t>
             </a:fld>
             <a:endParaRPr lang="en-US"/>
           </a:p>
@@ -1763,7 +1768,7 @@
           <a:p>
             <a:fld id="{6028BAED-B89A-EC45-9ABA-871B3199639E}" type="datetimeFigureOut">
               <a:rPr lang="en-US" smtClean="0"/>
-              <a:t>4/28/26</a:t>
+              <a:t>4/29/26</a:t>
             </a:fld>
             <a:endParaRPr lang="en-US"/>
           </a:p>
@@ -2077,7 +2082,7 @@
           <a:p>
             <a:fld id="{6028BAED-B89A-EC45-9ABA-871B3199639E}" type="datetimeFigureOut">
               <a:rPr lang="en-US" smtClean="0"/>
-              <a:t>4/28/26</a:t>
+              <a:t>4/29/26</a:t>
             </a:fld>
             <a:endParaRPr lang="en-US"/>
           </a:p>
@@ -2470,7 +2475,7 @@
           <a:p>
             <a:fld id="{6028BAED-B89A-EC45-9ABA-871B3199639E}" type="datetimeFigureOut">
               <a:rPr lang="en-US" smtClean="0"/>
-              <a:t>4/28/26</a:t>
+              <a:t>4/29/26</a:t>
             </a:fld>
             <a:endParaRPr lang="en-US"/>
           </a:p>
@@ -2640,7 +2645,7 @@
           <a:p>
             <a:fld id="{6028BAED-B89A-EC45-9ABA-871B3199639E}" type="datetimeFigureOut">
               <a:rPr lang="en-US" smtClean="0"/>
-              <a:t>4/28/26</a:t>
+              <a:t>4/29/26</a:t>
             </a:fld>
             <a:endParaRPr lang="en-US"/>
           </a:p>
@@ -2820,7 +2825,7 @@
           <a:p>
             <a:fld id="{6028BAED-B89A-EC45-9ABA-871B3199639E}" type="datetimeFigureOut">
               <a:rPr lang="en-US" smtClean="0"/>
-              <a:t>4/28/26</a:t>
+              <a:t>4/29/26</a:t>
             </a:fld>
             <a:endParaRPr lang="en-US"/>
           </a:p>
@@ -2990,7 +2995,7 @@
           <a:p>
             <a:fld id="{6028BAED-B89A-EC45-9ABA-871B3199639E}" type="datetimeFigureOut">
               <a:rPr lang="en-US" smtClean="0"/>
-              <a:t>4/28/26</a:t>
+              <a:t>4/29/26</a:t>
             </a:fld>
             <a:endParaRPr lang="en-US"/>
           </a:p>
@@ -3237,7 +3242,7 @@
           <a:p>
             <a:fld id="{6028BAED-B89A-EC45-9ABA-871B3199639E}" type="datetimeFigureOut">
               <a:rPr lang="en-US" smtClean="0"/>
-              <a:t>4/28/26</a:t>
+              <a:t>4/29/26</a:t>
             </a:fld>
             <a:endParaRPr lang="en-US"/>
           </a:p>
@@ -3469,7 +3474,7 @@
           <a:p>
             <a:fld id="{6028BAED-B89A-EC45-9ABA-871B3199639E}" type="datetimeFigureOut">
               <a:rPr lang="en-US" smtClean="0"/>
-              <a:t>4/28/26</a:t>
+              <a:t>4/29/26</a:t>
             </a:fld>
             <a:endParaRPr lang="en-US"/>
           </a:p>
@@ -3843,7 +3848,7 @@
           <a:p>
             <a:fld id="{6028BAED-B89A-EC45-9ABA-871B3199639E}" type="datetimeFigureOut">
               <a:rPr lang="en-US" smtClean="0"/>
-              <a:t>4/28/26</a:t>
+              <a:t>4/29/26</a:t>
             </a:fld>
             <a:endParaRPr lang="en-US"/>
           </a:p>
@@ -3966,7 +3971,7 @@
           <a:p>
             <a:fld id="{6028BAED-B89A-EC45-9ABA-871B3199639E}" type="datetimeFigureOut">
               <a:rPr lang="en-US" smtClean="0"/>
-              <a:t>4/28/26</a:t>
+              <a:t>4/29/26</a:t>
             </a:fld>
             <a:endParaRPr lang="en-US"/>
           </a:p>
@@ -4061,7 +4066,7 @@
           <a:p>
             <a:fld id="{6028BAED-B89A-EC45-9ABA-871B3199639E}" type="datetimeFigureOut">
               <a:rPr lang="en-US" smtClean="0"/>
-              <a:t>4/28/26</a:t>
+              <a:t>4/29/26</a:t>
             </a:fld>
             <a:endParaRPr lang="en-US"/>
           </a:p>
@@ -4316,7 +4321,7 @@
           <a:p>
             <a:fld id="{6028BAED-B89A-EC45-9ABA-871B3199639E}" type="datetimeFigureOut">
               <a:rPr lang="en-US" smtClean="0"/>
-              <a:t>4/28/26</a:t>
+              <a:t>4/29/26</a:t>
             </a:fld>
             <a:endParaRPr lang="en-US"/>
           </a:p>
@@ -4621,7 +4626,7 @@
           <a:p>
             <a:fld id="{6028BAED-B89A-EC45-9ABA-871B3199639E}" type="datetimeFigureOut">
               <a:rPr lang="en-US" smtClean="0"/>
-              <a:t>4/28/26</a:t>
+              <a:t>4/29/26</a:t>
             </a:fld>
             <a:endParaRPr lang="en-US"/>
           </a:p>
@@ -5323,7 +5328,7 @@
           <a:p>
             <a:fld id="{6028BAED-B89A-EC45-9ABA-871B3199639E}" type="datetimeFigureOut">
               <a:rPr lang="en-US" smtClean="0"/>
-              <a:t>4/28/26</a:t>
+              <a:t>4/29/26</a:t>
             </a:fld>
             <a:endParaRPr lang="en-US"/>
           </a:p>
@@ -5938,99 +5943,6 @@
           <p:cNvPr id="2" name="Title 1">
             <a:extLst>
               <a:ext uri="{FF2B5EF4-FFF2-40B4-BE49-F238E27FC236}">
-                <a16:creationId xmlns:a16="http://schemas.microsoft.com/office/drawing/2014/main" id="{A235262A-081A-24E0-CCE6-B774C7BB0FC0}"/>
-              </a:ext>
-            </a:extLst>
-          </p:cNvPr>
-          <p:cNvSpPr>
-            <a:spLocks noGrp="1"/>
-          </p:cNvSpPr>
-          <p:nvPr>
-            <p:ph type="title"/>
-          </p:nvPr>
-        </p:nvSpPr>
-        <p:spPr/>
-        <p:txBody>
-          <a:bodyPr/>
-          <a:lstStyle/>
-          <a:p>
-            <a:r>
-              <a:rPr lang="en-US" dirty="0"/>
-              <a:t>Fine-tuned model: </a:t>
-            </a:r>
-            <a:r>
-              <a:rPr lang="en-US"/>
-              <a:t>compressor is key</a:t>
-            </a:r>
-            <a:endParaRPr lang="en-US" dirty="0"/>
-          </a:p>
-        </p:txBody>
-      </p:sp>
-      <p:pic>
-        <p:nvPicPr>
-          <p:cNvPr id="5" name="Picture 4" descr="A graph of different colored bars&#10;&#10;AI-generated content may be incorrect.">
-            <a:extLst>
-              <a:ext uri="{FF2B5EF4-FFF2-40B4-BE49-F238E27FC236}">
-                <a16:creationId xmlns:a16="http://schemas.microsoft.com/office/drawing/2014/main" id="{FB412E65-3D4E-5F53-2DB0-46A7346331AA}"/>
-              </a:ext>
-            </a:extLst>
-          </p:cNvPr>
-          <p:cNvPicPr>
-            <a:picLocks noChangeAspect="1"/>
-          </p:cNvPicPr>
-          <p:nvPr/>
-        </p:nvPicPr>
-        <p:blipFill>
-          <a:blip r:embed="rId2"/>
-          <a:stretch>
-            <a:fillRect/>
-          </a:stretch>
-        </p:blipFill>
-        <p:spPr>
-          <a:xfrm>
-            <a:off x="677334" y="2032000"/>
-            <a:ext cx="7772400" cy="4625831"/>
-          </a:xfrm>
-          <a:prstGeom prst="rect">
-            <a:avLst/>
-          </a:prstGeom>
-        </p:spPr>
-      </p:pic>
-    </p:spTree>
-    <p:extLst>
-      <p:ext uri="{BB962C8B-B14F-4D97-AF65-F5344CB8AC3E}">
-        <p14:creationId xmlns:p14="http://schemas.microsoft.com/office/powerpoint/2010/main" val="596074855"/>
-      </p:ext>
-    </p:extLst>
-  </p:cSld>
-  <p:clrMapOvr>
-    <a:masterClrMapping/>
-  </p:clrMapOvr>
-</p:sld>
-</file>
-
-<file path=ppt/slides/slide11.xml><?xml version="1.0" encoding="utf-8"?>
-<p:sld xmlns:a="http://schemas.openxmlformats.org/drawingml/2006/main" xmlns:r="http://schemas.openxmlformats.org/officeDocument/2006/relationships" xmlns:p="http://schemas.openxmlformats.org/presentationml/2006/main">
-  <p:cSld>
-    <p:spTree>
-      <p:nvGrpSpPr>
-        <p:cNvPr id="1" name=""/>
-        <p:cNvGrpSpPr/>
-        <p:nvPr/>
-      </p:nvGrpSpPr>
-      <p:grpSpPr>
-        <a:xfrm>
-          <a:off x="0" y="0"/>
-          <a:ext cx="0" cy="0"/>
-          <a:chOff x="0" y="0"/>
-          <a:chExt cx="0" cy="0"/>
-        </a:xfrm>
-      </p:grpSpPr>
-      <p:sp>
-        <p:nvSpPr>
-          <p:cNvPr id="2" name="Title 1">
-            <a:extLst>
-              <a:ext uri="{FF2B5EF4-FFF2-40B4-BE49-F238E27FC236}">
                 <a16:creationId xmlns:a16="http://schemas.microsoft.com/office/drawing/2014/main" id="{CA5EA34F-43E0-94C1-C0F2-F4C1F4B95512}"/>
               </a:ext>
             </a:extLst>
@@ -6110,14 +6022,21 @@
             <a:pPr lvl="1"/>
             <a:r>
               <a:rPr lang="en-US" dirty="0"/>
-              <a:t>Spurious Mantissa bit compression?</a:t>
+              <a:t>Application to model checkpoints?</a:t>
             </a:r>
           </a:p>
           <a:p>
             <a:pPr lvl="1"/>
             <a:r>
               <a:rPr lang="en-US" dirty="0"/>
-              <a:t>Application to model checkpoints?</a:t>
+              <a:t>Pareto distribution for weights by layer?</a:t>
+            </a:r>
+          </a:p>
+          <a:p>
+            <a:pPr lvl="1"/>
+            <a:r>
+              <a:rPr lang="en-US" dirty="0"/>
+              <a:t>General analysis on a representative set of model weights across families</a:t>
             </a:r>
           </a:p>
           <a:p>
@@ -6142,7 +6061,7 @@
 </p:sld>
 </file>
 
-<file path=ppt/slides/slide12.xml><?xml version="1.0" encoding="utf-8"?>
+<file path=ppt/slides/slide11.xml><?xml version="1.0" encoding="utf-8"?>
 <p:sld xmlns:a="http://schemas.openxmlformats.org/drawingml/2006/main" xmlns:r="http://schemas.openxmlformats.org/officeDocument/2006/relationships" xmlns:p="http://schemas.openxmlformats.org/presentationml/2006/main">
   <p:cSld>
     <p:spTree>
@@ -6221,6 +6140,94 @@
     <p:extLst>
       <p:ext uri="{BB962C8B-B14F-4D97-AF65-F5344CB8AC3E}">
         <p14:creationId xmlns:p14="http://schemas.microsoft.com/office/powerpoint/2010/main" val="4038837584"/>
+      </p:ext>
+    </p:extLst>
+  </p:cSld>
+  <p:clrMapOvr>
+    <a:masterClrMapping/>
+  </p:clrMapOvr>
+</p:sld>
+</file>
+
+<file path=ppt/slides/slide12.xml><?xml version="1.0" encoding="utf-8"?>
+<p:sld xmlns:a="http://schemas.openxmlformats.org/drawingml/2006/main" xmlns:r="http://schemas.openxmlformats.org/officeDocument/2006/relationships" xmlns:p="http://schemas.openxmlformats.org/presentationml/2006/main">
+  <p:cSld>
+    <p:spTree>
+      <p:nvGrpSpPr>
+        <p:cNvPr id="1" name=""/>
+        <p:cNvGrpSpPr/>
+        <p:nvPr/>
+      </p:nvGrpSpPr>
+      <p:grpSpPr>
+        <a:xfrm>
+          <a:off x="0" y="0"/>
+          <a:ext cx="0" cy="0"/>
+          <a:chOff x="0" y="0"/>
+          <a:chExt cx="0" cy="0"/>
+        </a:xfrm>
+      </p:grpSpPr>
+      <p:sp>
+        <p:nvSpPr>
+          <p:cNvPr id="2" name="Title 1">
+            <a:extLst>
+              <a:ext uri="{FF2B5EF4-FFF2-40B4-BE49-F238E27FC236}">
+                <a16:creationId xmlns:a16="http://schemas.microsoft.com/office/drawing/2014/main" id="{2A2BE0C1-B4EF-7651-348F-8E6819C6EFD7}"/>
+              </a:ext>
+            </a:extLst>
+          </p:cNvPr>
+          <p:cNvSpPr>
+            <a:spLocks noGrp="1"/>
+          </p:cNvSpPr>
+          <p:nvPr>
+            <p:ph type="title"/>
+          </p:nvPr>
+        </p:nvSpPr>
+        <p:spPr/>
+        <p:txBody>
+          <a:bodyPr/>
+          <a:lstStyle/>
+          <a:p>
+            <a:r>
+              <a:rPr lang="en-US" dirty="0"/>
+              <a:t>Mantissa bits compress under semantic split</a:t>
+            </a:r>
+          </a:p>
+        </p:txBody>
+      </p:sp>
+      <p:pic>
+        <p:nvPicPr>
+          <p:cNvPr id="5" name="Picture 4" descr="A graph of different colored columns&#10;&#10;AI-generated content may be incorrect.">
+            <a:extLst>
+              <a:ext uri="{FF2B5EF4-FFF2-40B4-BE49-F238E27FC236}">
+                <a16:creationId xmlns:a16="http://schemas.microsoft.com/office/drawing/2014/main" id="{03020A39-8E67-DF0B-8136-E70DEA4CD4CB}"/>
+              </a:ext>
+            </a:extLst>
+          </p:cNvPr>
+          <p:cNvPicPr>
+            <a:picLocks noChangeAspect="1"/>
+          </p:cNvPicPr>
+          <p:nvPr/>
+        </p:nvPicPr>
+        <p:blipFill>
+          <a:blip r:embed="rId2"/>
+          <a:stretch>
+            <a:fillRect/>
+          </a:stretch>
+        </p:blipFill>
+        <p:spPr>
+          <a:xfrm>
+            <a:off x="677334" y="2071396"/>
+            <a:ext cx="7772400" cy="4177004"/>
+          </a:xfrm>
+          <a:prstGeom prst="rect">
+            <a:avLst/>
+          </a:prstGeom>
+        </p:spPr>
+      </p:pic>
+    </p:spTree>
+    <p:extLst>
+      <p:ext uri="{BB962C8B-B14F-4D97-AF65-F5344CB8AC3E}">
+        <p14:creationId xmlns:p14="http://schemas.microsoft.com/office/powerpoint/2010/main" val="3222843991"/>
       </p:ext>
     </p:extLst>
   </p:cSld>
@@ -8108,94 +8115,6 @@
   <p:cSld>
     <p:spTree>
       <p:nvGrpSpPr>
-        <p:cNvPr id="1" name=""/>
-        <p:cNvGrpSpPr/>
-        <p:nvPr/>
-      </p:nvGrpSpPr>
-      <p:grpSpPr>
-        <a:xfrm>
-          <a:off x="0" y="0"/>
-          <a:ext cx="0" cy="0"/>
-          <a:chOff x="0" y="0"/>
-          <a:chExt cx="0" cy="0"/>
-        </a:xfrm>
-      </p:grpSpPr>
-      <p:sp>
-        <p:nvSpPr>
-          <p:cNvPr id="2" name="Title 1">
-            <a:extLst>
-              <a:ext uri="{FF2B5EF4-FFF2-40B4-BE49-F238E27FC236}">
-                <a16:creationId xmlns:a16="http://schemas.microsoft.com/office/drawing/2014/main" id="{2A2BE0C1-B4EF-7651-348F-8E6819C6EFD7}"/>
-              </a:ext>
-            </a:extLst>
-          </p:cNvPr>
-          <p:cNvSpPr>
-            <a:spLocks noGrp="1"/>
-          </p:cNvSpPr>
-          <p:nvPr>
-            <p:ph type="title"/>
-          </p:nvPr>
-        </p:nvSpPr>
-        <p:spPr/>
-        <p:txBody>
-          <a:bodyPr/>
-          <a:lstStyle/>
-          <a:p>
-            <a:r>
-              <a:rPr lang="en-US" dirty="0"/>
-              <a:t>Mantissa bits compress under semantic split</a:t>
-            </a:r>
-          </a:p>
-        </p:txBody>
-      </p:sp>
-      <p:pic>
-        <p:nvPicPr>
-          <p:cNvPr id="5" name="Picture 4" descr="A graph of different colored columns&#10;&#10;AI-generated content may be incorrect.">
-            <a:extLst>
-              <a:ext uri="{FF2B5EF4-FFF2-40B4-BE49-F238E27FC236}">
-                <a16:creationId xmlns:a16="http://schemas.microsoft.com/office/drawing/2014/main" id="{03020A39-8E67-DF0B-8136-E70DEA4CD4CB}"/>
-              </a:ext>
-            </a:extLst>
-          </p:cNvPr>
-          <p:cNvPicPr>
-            <a:picLocks noChangeAspect="1"/>
-          </p:cNvPicPr>
-          <p:nvPr/>
-        </p:nvPicPr>
-        <p:blipFill>
-          <a:blip r:embed="rId2"/>
-          <a:stretch>
-            <a:fillRect/>
-          </a:stretch>
-        </p:blipFill>
-        <p:spPr>
-          <a:xfrm>
-            <a:off x="677334" y="2071396"/>
-            <a:ext cx="7772400" cy="4177004"/>
-          </a:xfrm>
-          <a:prstGeom prst="rect">
-            <a:avLst/>
-          </a:prstGeom>
-        </p:spPr>
-      </p:pic>
-    </p:spTree>
-    <p:extLst>
-      <p:ext uri="{BB962C8B-B14F-4D97-AF65-F5344CB8AC3E}">
-        <p14:creationId xmlns:p14="http://schemas.microsoft.com/office/powerpoint/2010/main" val="3222843991"/>
-      </p:ext>
-    </p:extLst>
-  </p:cSld>
-  <p:clrMapOvr>
-    <a:masterClrMapping/>
-  </p:clrMapOvr>
-</p:sld>
-</file>
-
-<file path=ppt/slides/slide9.xml><?xml version="1.0" encoding="utf-8"?>
-<p:sld xmlns:a="http://schemas.openxmlformats.org/drawingml/2006/main" xmlns:r="http://schemas.openxmlformats.org/officeDocument/2006/relationships" xmlns:p="http://schemas.openxmlformats.org/presentationml/2006/main">
-  <p:cSld>
-    <p:spTree>
-      <p:nvGrpSpPr>
         <p:cNvPr id="1" name="">
           <a:extLst>
             <a:ext uri="{FF2B5EF4-FFF2-40B4-BE49-F238E27FC236}">
@@ -8798,6 +8717,104 @@
     <p:extLst>
       <p:ext uri="{BB962C8B-B14F-4D97-AF65-F5344CB8AC3E}">
         <p14:creationId xmlns:p14="http://schemas.microsoft.com/office/powerpoint/2010/main" val="3450119407"/>
+      </p:ext>
+    </p:extLst>
+  </p:cSld>
+  <p:clrMapOvr>
+    <a:masterClrMapping/>
+  </p:clrMapOvr>
+</p:sld>
+</file>
+
+<file path=ppt/slides/slide9.xml><?xml version="1.0" encoding="utf-8"?>
+<p:sld xmlns:a="http://schemas.openxmlformats.org/drawingml/2006/main" xmlns:r="http://schemas.openxmlformats.org/officeDocument/2006/relationships" xmlns:p="http://schemas.openxmlformats.org/presentationml/2006/main">
+  <p:cSld>
+    <p:spTree>
+      <p:nvGrpSpPr>
+        <p:cNvPr id="1" name=""/>
+        <p:cNvGrpSpPr/>
+        <p:nvPr/>
+      </p:nvGrpSpPr>
+      <p:grpSpPr>
+        <a:xfrm>
+          <a:off x="0" y="0"/>
+          <a:ext cx="0" cy="0"/>
+          <a:chOff x="0" y="0"/>
+          <a:chExt cx="0" cy="0"/>
+        </a:xfrm>
+      </p:grpSpPr>
+      <p:sp>
+        <p:nvSpPr>
+          <p:cNvPr id="2" name="Title 1">
+            <a:extLst>
+              <a:ext uri="{FF2B5EF4-FFF2-40B4-BE49-F238E27FC236}">
+                <a16:creationId xmlns:a16="http://schemas.microsoft.com/office/drawing/2014/main" id="{A235262A-081A-24E0-CCE6-B774C7BB0FC0}"/>
+              </a:ext>
+            </a:extLst>
+          </p:cNvPr>
+          <p:cNvSpPr>
+            <a:spLocks noGrp="1"/>
+          </p:cNvSpPr>
+          <p:nvPr>
+            <p:ph type="title"/>
+          </p:nvPr>
+        </p:nvSpPr>
+        <p:spPr/>
+        <p:txBody>
+          <a:bodyPr>
+            <a:normAutofit/>
+          </a:bodyPr>
+          <a:lstStyle/>
+          <a:p>
+            <a:r>
+              <a:rPr lang="en-US" dirty="0"/>
+              <a:t>Fine-tuned model: XOR Delta is </a:t>
+            </a:r>
+            <a:r>
+              <a:rPr lang="en-US"/>
+              <a:t>strong Compressor </a:t>
+            </a:r>
+            <a:r>
+              <a:rPr lang="en-US" dirty="0"/>
+              <a:t>is key for improvements</a:t>
+            </a:r>
+          </a:p>
+        </p:txBody>
+      </p:sp>
+      <p:pic>
+        <p:nvPicPr>
+          <p:cNvPr id="5" name="Picture 4" descr="A graph of different colored bars&#10;&#10;AI-generated content may be incorrect.">
+            <a:extLst>
+              <a:ext uri="{FF2B5EF4-FFF2-40B4-BE49-F238E27FC236}">
+                <a16:creationId xmlns:a16="http://schemas.microsoft.com/office/drawing/2014/main" id="{FB412E65-3D4E-5F53-2DB0-46A7346331AA}"/>
+              </a:ext>
+            </a:extLst>
+          </p:cNvPr>
+          <p:cNvPicPr>
+            <a:picLocks noChangeAspect="1"/>
+          </p:cNvPicPr>
+          <p:nvPr/>
+        </p:nvPicPr>
+        <p:blipFill>
+          <a:blip r:embed="rId2"/>
+          <a:stretch>
+            <a:fillRect/>
+          </a:stretch>
+        </p:blipFill>
+        <p:spPr>
+          <a:xfrm>
+            <a:off x="677334" y="2032000"/>
+            <a:ext cx="7772400" cy="4625831"/>
+          </a:xfrm>
+          <a:prstGeom prst="rect">
+            <a:avLst/>
+          </a:prstGeom>
+        </p:spPr>
+      </p:pic>
+    </p:spTree>
+    <p:extLst>
+      <p:ext uri="{BB962C8B-B14F-4D97-AF65-F5344CB8AC3E}">
+        <p14:creationId xmlns:p14="http://schemas.microsoft.com/office/powerpoint/2010/main" val="596074855"/>
       </p:ext>
     </p:extLst>
   </p:cSld>

</xml_diff>